<commit_message>
test acitive multi banking
</commit_message>
<xml_diff>
--- a/doc/Präsentation_SGLOOR.pptx
+++ b/doc/Präsentation_SGLOOR.pptx
@@ -1206,7 +1206,8 @@
               <a:buNone/>
             </a:pPr>
             <a:r>
-              <a:t/>
+              <a:rPr lang="de-CH" sz="2000"/>
+              <a:t>Test-Pyramide von Mike Cohn</a:t>
             </a:r>
             <a:endParaRPr b="0" sz="2000" strike="noStrike">
               <a:latin typeface="Arial"/>
@@ -1367,6 +1368,34 @@
           <a:lstStyle/>
           <a:p>
             <a:pPr indent="0" lvl="0" marL="216000" rtl="0" algn="l">
+              <a:spcBef>
+                <a:spcPts val="0"/>
+              </a:spcBef>
+              <a:spcAft>
+                <a:spcPts val="0"/>
+              </a:spcAft>
+              <a:buClr>
+                <a:schemeClr val="dk1"/>
+              </a:buClr>
+              <a:buFont typeface="Arial"/>
+              <a:buNone/>
+            </a:pPr>
+            <a:r>
+              <a:rPr lang="de-CH" sz="2000">
+                <a:solidFill>
+                  <a:schemeClr val="dk1"/>
+                </a:solidFill>
+              </a:rPr>
+              <a:t>Test-Pyramide von Mike Cohn</a:t>
+            </a:r>
+            <a:endParaRPr sz="2000">
+              <a:solidFill>
+                <a:schemeClr val="dk1"/>
+              </a:solidFill>
+            </a:endParaRPr>
+          </a:p>
+          <a:p>
+            <a:pPr indent="0" lvl="0" marL="216000" rtl="0" algn="l">
               <a:lnSpc>
                 <a:spcPct val="100000"/>
               </a:lnSpc>
@@ -1381,12 +1410,7 @@
             <a:r>
               <a:t/>
             </a:r>
-            <a:endParaRPr b="0" sz="2000" strike="noStrike">
-              <a:latin typeface="Arial"/>
-              <a:ea typeface="Arial"/>
-              <a:cs typeface="Arial"/>
-              <a:sym typeface="Arial"/>
-            </a:endParaRPr>
+            <a:endParaRPr sz="2000"/>
           </a:p>
         </p:txBody>
       </p:sp>
@@ -1540,6 +1564,34 @@
           <a:lstStyle/>
           <a:p>
             <a:pPr indent="0" lvl="0" marL="216000" rtl="0" algn="l">
+              <a:spcBef>
+                <a:spcPts val="0"/>
+              </a:spcBef>
+              <a:spcAft>
+                <a:spcPts val="0"/>
+              </a:spcAft>
+              <a:buClr>
+                <a:schemeClr val="dk1"/>
+              </a:buClr>
+              <a:buFont typeface="Arial"/>
+              <a:buNone/>
+            </a:pPr>
+            <a:r>
+              <a:rPr lang="de-CH" sz="2000">
+                <a:solidFill>
+                  <a:schemeClr val="dk1"/>
+                </a:solidFill>
+              </a:rPr>
+              <a:t>Test-Pyramide von Mike Cohn</a:t>
+            </a:r>
+            <a:endParaRPr sz="2000">
+              <a:solidFill>
+                <a:schemeClr val="dk1"/>
+              </a:solidFill>
+            </a:endParaRPr>
+          </a:p>
+          <a:p>
+            <a:pPr indent="0" lvl="0" marL="216000" rtl="0" algn="l">
               <a:lnSpc>
                 <a:spcPct val="100000"/>
               </a:lnSpc>
@@ -1554,12 +1606,7 @@
             <a:r>
               <a:t/>
             </a:r>
-            <a:endParaRPr b="0" sz="2000" strike="noStrike">
-              <a:latin typeface="Arial"/>
-              <a:ea typeface="Arial"/>
-              <a:cs typeface="Arial"/>
-              <a:sym typeface="Arial"/>
-            </a:endParaRPr>
+            <a:endParaRPr sz="2000"/>
           </a:p>
         </p:txBody>
       </p:sp>
@@ -1713,6 +1760,34 @@
           <a:lstStyle/>
           <a:p>
             <a:pPr indent="0" lvl="0" marL="216000" rtl="0" algn="l">
+              <a:spcBef>
+                <a:spcPts val="0"/>
+              </a:spcBef>
+              <a:spcAft>
+                <a:spcPts val="0"/>
+              </a:spcAft>
+              <a:buClr>
+                <a:schemeClr val="dk1"/>
+              </a:buClr>
+              <a:buFont typeface="Arial"/>
+              <a:buNone/>
+            </a:pPr>
+            <a:r>
+              <a:rPr lang="de-CH" sz="2000">
+                <a:solidFill>
+                  <a:schemeClr val="dk1"/>
+                </a:solidFill>
+              </a:rPr>
+              <a:t>Test-Pyramide von Mike Cohn</a:t>
+            </a:r>
+            <a:endParaRPr sz="2000">
+              <a:solidFill>
+                <a:schemeClr val="dk1"/>
+              </a:solidFill>
+            </a:endParaRPr>
+          </a:p>
+          <a:p>
+            <a:pPr indent="0" lvl="0" marL="216000" rtl="0" algn="l">
               <a:lnSpc>
                 <a:spcPct val="100000"/>
               </a:lnSpc>
@@ -1727,12 +1802,7 @@
             <a:r>
               <a:t/>
             </a:r>
-            <a:endParaRPr b="0" sz="2000" strike="noStrike">
-              <a:latin typeface="Arial"/>
-              <a:ea typeface="Arial"/>
-              <a:cs typeface="Arial"/>
-              <a:sym typeface="Arial"/>
-            </a:endParaRPr>
+            <a:endParaRPr sz="2000"/>
           </a:p>
         </p:txBody>
       </p:sp>
@@ -1886,6 +1956,34 @@
           <a:lstStyle/>
           <a:p>
             <a:pPr indent="0" lvl="0" marL="216000" rtl="0" algn="l">
+              <a:spcBef>
+                <a:spcPts val="0"/>
+              </a:spcBef>
+              <a:spcAft>
+                <a:spcPts val="0"/>
+              </a:spcAft>
+              <a:buClr>
+                <a:schemeClr val="dk1"/>
+              </a:buClr>
+              <a:buFont typeface="Arial"/>
+              <a:buNone/>
+            </a:pPr>
+            <a:r>
+              <a:rPr lang="de-CH" sz="2000">
+                <a:solidFill>
+                  <a:schemeClr val="dk1"/>
+                </a:solidFill>
+              </a:rPr>
+              <a:t>Test-Pyramide von Mike Cohn</a:t>
+            </a:r>
+            <a:endParaRPr sz="2000">
+              <a:solidFill>
+                <a:schemeClr val="dk1"/>
+              </a:solidFill>
+            </a:endParaRPr>
+          </a:p>
+          <a:p>
+            <a:pPr indent="0" lvl="0" marL="216000" rtl="0" algn="l">
               <a:lnSpc>
                 <a:spcPct val="100000"/>
               </a:lnSpc>
@@ -1900,12 +1998,7 @@
             <a:r>
               <a:t/>
             </a:r>
-            <a:endParaRPr b="0" sz="2000" strike="noStrike">
-              <a:latin typeface="Arial"/>
-              <a:ea typeface="Arial"/>
-              <a:cs typeface="Arial"/>
-              <a:sym typeface="Arial"/>
-            </a:endParaRPr>
+            <a:endParaRPr sz="2000"/>
           </a:p>
         </p:txBody>
       </p:sp>
@@ -2059,6 +2152,34 @@
           <a:lstStyle/>
           <a:p>
             <a:pPr indent="0" lvl="0" marL="216000" rtl="0" algn="l">
+              <a:spcBef>
+                <a:spcPts val="0"/>
+              </a:spcBef>
+              <a:spcAft>
+                <a:spcPts val="0"/>
+              </a:spcAft>
+              <a:buClr>
+                <a:schemeClr val="dk1"/>
+              </a:buClr>
+              <a:buFont typeface="Arial"/>
+              <a:buNone/>
+            </a:pPr>
+            <a:r>
+              <a:rPr lang="de-CH" sz="2000">
+                <a:solidFill>
+                  <a:schemeClr val="dk1"/>
+                </a:solidFill>
+              </a:rPr>
+              <a:t>Test-Pyramide von Mike Cohn</a:t>
+            </a:r>
+            <a:endParaRPr sz="2000">
+              <a:solidFill>
+                <a:schemeClr val="dk1"/>
+              </a:solidFill>
+            </a:endParaRPr>
+          </a:p>
+          <a:p>
+            <a:pPr indent="0" lvl="0" marL="216000" rtl="0" algn="l">
               <a:lnSpc>
                 <a:spcPct val="100000"/>
               </a:lnSpc>
@@ -2073,12 +2194,7 @@
             <a:r>
               <a:t/>
             </a:r>
-            <a:endParaRPr b="0" sz="2000" strike="noStrike">
-              <a:latin typeface="Arial"/>
-              <a:ea typeface="Arial"/>
-              <a:cs typeface="Arial"/>
-              <a:sym typeface="Arial"/>
-            </a:endParaRPr>
+            <a:endParaRPr sz="2000"/>
           </a:p>
         </p:txBody>
       </p:sp>
@@ -8898,7 +9014,7 @@
         <p:spPr>
           <a:xfrm>
             <a:off x="5040000" y="1584000"/>
-            <a:ext cx="6768000" cy="4824000"/>
+            <a:ext cx="6768000" cy="5808900"/>
           </a:xfrm>
           <a:prstGeom prst="rect">
             <a:avLst/>

</xml_diff>